<commit_message>
feat(ooad): S07-S14 sessions, integration/feedback code, renderer fixes
- Sessions S07-S14 with verified citations (Larman 3rd ed. only) and
  runnable Java under code/s07..s14 (S13 has no code)
- Glossary-aware enum check; S02-S06 glossary and citation updates
- Renderer: text/plaintext blocks render as code; long session names
  shrink to one line in the header (guide and tests updated)

Co-Authored-By: Claude Opus 5.5 <noreply@anthropic.com>
</commit_message>
<xml_diff>
--- a/courses/ooad/sessions/s06.pptx
+++ b/courses/ooad/sessions/s06.pptx
@@ -1554,7 +1554,7 @@
             <a:pPr lvl="0"/>
             <a:r>
               <a:rPr lang="ko-KR" sz="1200"/>
-              <a:t>시스템 이벤트를 받는 객체를 정하는 원칙은 GRASP의 Controller로도 설명한다. 원칙의 이름과 대안은 "08. 변화 대응과 변이 설계"의 GRASP에서 함께 다룬다. 여기서는 판단 근거(규칙과 조정의 분리)만 본다.</a:t>
+              <a:t>시스템 이벤트를 받는 객체를 정하는 원칙은 GRASP의 컨트롤러(Controller)다. GRASP는 "07. 책임·협력·계약"의 「07. GRASP」에서 소개한다. 여기서는 판단 근거(규칙과 조정의 분리)만 본다.</a:t>
             </a:r>
           </a:p>
           <a:p>
@@ -2154,7 +2154,7 @@
             <a:pPr lvl="0"/>
             <a:r>
               <a:rPr lang="ko-KR" sz="1200"/>
-              <a:t>인용 근거: Craig Larman, *Applying UML and Patterns*, 2nd ed., Chapter 10 "Finding Conceptual Classes with Noun Phrase Identification" 원문 확인. "03. 정적 모델 — 도메인 개념과 관계"의 「44. 도메인 모델 — 초안」 앞의 개념 찾기와 같은 절의 다른 문장이다.</a:t>
+              <a:t>인용 근거: Craig Larman, *Applying UML and Patterns*, 3rd ed.(2004), §9.5 "Method 3: Finding Conceptual Classes with Noun Phrase Identification" 원문 확인. "03. 정적 모델 — 도메인 개념과 관계"의 「44. 도메인 모델 — 초안」 앞의 개념 찾기와 같은 절의 다른 문장이다.</a:t>
             </a:r>
           </a:p>
           <a:p>
@@ -3019,7 +3019,7 @@
             <a:pPr lvl="0"/>
             <a:r>
               <a:rPr lang="ko-KR" sz="1200"/>
-              <a:t>인용 근거: Craig Larman, *Applying UML and Patterns*, 3rd ed., 2004, p.272. 원서 본문은 미확인이다(www). 재인용처: Wikipedia "GRASP (object-oriented design)"의 인용문과 서지(3판 p.272)를 확인했다. 2판에는 이 문장이 없다.</a:t>
+              <a:t>인용 근거: Craig Larman, *Applying UML and Patterns*, 3rd ed.(2004), §17.1 "UML versus Design Principles" 원문 확인.</a:t>
             </a:r>
           </a:p>
           <a:p>
@@ -3169,14 +3169,14 @@
             <a:pPr lvl="0"/>
             <a:r>
               <a:rPr lang="ko-KR" sz="1200"/>
-              <a:t>인용 근거: Craig Larman, *Applying UML and Patterns*, 2nd ed., §10.9 "Lowering the Representational Gap" 원문 확인.</a:t>
+              <a:t>인용 근거: Craig Larman, *Applying UML and Patterns*, 3rd ed.(2004), §9.3 "Motivation: Why Create a Domain Model?"의 "Motivation: Lower Representational Gap with OO Modeling" 원문 확인.</a:t>
             </a:r>
           </a:p>
           <a:p>
             <a:pPr lvl="0"/>
             <a:r>
               <a:rPr lang="ko-KR" sz="1200"/>
-              <a:t>첫 인용의 "일부 요소(some things)"에 주목한다. 도메인 모델은 모든 설계 요소의 원본이 아니다. 주문 서비스·주문 저장소처럼 도메인 모델에 없는 설계 요소도 있다.</a:t>
+              <a:t>첫 인용의 "도메인 계층(domain layer)"에 주목한다. 도메인 모델에서 이름을 얻는 것은 도메인 계층의 클래스다. 주문 서비스·주문 저장소처럼 도메인 모델에 없는 설계 요소도 있다.</a:t>
             </a:r>
           </a:p>
           <a:p>
@@ -29576,7 +29576,7 @@
                 <a:latin typeface="맑은 고딕"/>
                 <a:ea typeface="맑은 고딕"/>
               </a:rPr>
-              <a:t>Craig Larman, 2002</a:t>
+              <a:t>Craig Larman, 2004</a:t>
             </a:r>
           </a:p>
         </p:txBody>
@@ -40018,7 +40018,7 @@
                 <a:latin typeface="맑은 고딕"/>
                 <a:ea typeface="맑은 고딕"/>
               </a:rPr>
-              <a:t>"the critical design tool for software development is a mind well educated in design principles. It is not UML or any other technology."</a:t>
+              <a:t>"The critical design tool for software development is a mind well educated in design principles. It is not the UML or any other technology."</a:t>
             </a:r>
             <a:r>
               <a:rPr sz="1000" b="0">
@@ -40038,7 +40038,7 @@
                 <a:latin typeface="맑은 고딕"/>
                 <a:ea typeface="맑은 고딕"/>
               </a:rPr>
-              <a:t>Craig Larman, 2004, www</a:t>
+              <a:t>Craig Larman, 2004</a:t>
             </a:r>
           </a:p>
         </p:txBody>
@@ -42058,7 +42058,7 @@
                 <a:latin typeface="맑은 고딕"/>
                 <a:ea typeface="맑은 고딕"/>
               </a:rPr>
-              <a:t>"도메인 모델은 도메인 어휘와 개념의 시각적 사전이며, 설계에서 일부 요소의 </a:t>
+              <a:t>"도메인 계층의 소프트웨어 클래스 이름은 </a:t>
             </a:r>
             <a:r>
               <a:rPr sz="1800" b="1">
@@ -42068,7 +42068,7 @@
                 <a:latin typeface="맑은 고딕"/>
                 <a:ea typeface="맑은 고딕"/>
               </a:rPr>
-              <a:t>이름을 지을 때 영감</a:t>
+              <a:t>도메인 모델의 이름에서 영감</a:t>
             </a:r>
             <a:r>
               <a:rPr sz="1800" b="0">
@@ -42078,7 +42078,7 @@
                 <a:latin typeface="맑은 고딕"/>
                 <a:ea typeface="맑은 고딕"/>
               </a:rPr>
-              <a:t>을 얻는 곳이다"</a:t>
+              <a:t>을 얻고, 객체는 도메인에 익숙한 정보와 책임을 갖게 한다"</a:t>
             </a:r>
             <a:r>
               <a:rPr sz="1000" b="0">
@@ -42098,7 +42098,7 @@
                 <a:latin typeface="맑은 고딕"/>
                 <a:ea typeface="맑은 고딕"/>
               </a:rPr>
-              <a:t>"The Domain Model provides a visual dictionary of the domain vocabulary and concepts from which to draw inspiration for the naming of some things in the software design."</a:t>
+              <a:t>"Use software class names in the domain layer inspired from names in the domain model, with objects having domain-familiar information and responsibilities."</a:t>
             </a:r>
             <a:r>
               <a:rPr sz="1000" b="0">
@@ -42118,7 +42118,7 @@
                 <a:latin typeface="맑은 고딕"/>
                 <a:ea typeface="맑은 고딕"/>
               </a:rPr>
-              <a:t>Craig Larman, 2002</a:t>
+              <a:t>Craig Larman, 2004</a:t>
             </a:r>
           </a:p>
           <a:p>
@@ -42181,7 +42181,7 @@
                 <a:latin typeface="맑은 고딕"/>
                 <a:ea typeface="맑은 고딕"/>
               </a:rPr>
-              <a:t>"A lowered representational gap is useful, but arguably secondary to the advantage of objects to support ease of change and extension, and their support to manage and hide complexity."</a:t>
+              <a:t>"A lowered representational gap is useful, but arguably secondary to the advantage objects have in supporting ease of change and extension, and managing and hiding complexity."</a:t>
             </a:r>
             <a:r>
               <a:rPr sz="1000" b="0">
@@ -42201,7 +42201,7 @@
                 <a:latin typeface="맑은 고딕"/>
                 <a:ea typeface="맑은 고딕"/>
               </a:rPr>
-              <a:t>Craig Larman, 2002</a:t>
+              <a:t>Craig Larman, 2004</a:t>
             </a:r>
           </a:p>
           <a:p>

</xml_diff>